<commit_message>
Update slide 6 to use CTrees AGB 2000-2025 for carbon stability
Reflect the Tropical_forest_carbon_stability project data source and
strengthen CarbonARA links to BIOMASS validation and tower fluxes.

Co-authored-by: Mizanfwt04 <Mizanfwt04@users.noreply.github.com>
</commit_message>
<xml_diff>
--- a/CarbonARA_Interview_MdMizanRahman.pptx
+++ b/CarbonARA_Interview_MdMizanRahman.pptx
@@ -1073,7 +1073,7 @@
           <a:lstStyle/>
           <a:p>
             <a:r>
-              <a:t>~1.5 min. Replace bracketed figure with your actual Amazon map. Be honest: satellite pilot, not Amazon fieldwork yet.</a:t>
+              <a:t>~1.5 min. Emphasise CTrees AGB gives direct biomass carbon time series 2000–2025 at 100 m. This is stronger than NDVI-only for CarbonARA Theme II (vegetation carbon storage). Mention you apply same stability framework in Amazon and Sundarbans. CarbonARA can ground-truth with Tapajós towers, airborne structure, and BIOMASS/FLEX validation.</a:t>
             </a:r>
           </a:p>
         </p:txBody>
@@ -4546,7 +4546,7 @@
               </a:defRPr>
             </a:pPr>
             <a:r>
-              <a:t>Approach: test whether physiological/structural stress signals precede flux reversal — building on my hidden sink degradation &amp; AC1 framework</a:t>
+              <a:t>Approach: test whether physiological/structural stress signals (SIF, VOD, LST) precede AGB/flux decline — building on CTrees AGB stability analysis &amp; field-based hidden sink degradation</a:t>
             </a:r>
           </a:p>
         </p:txBody>
@@ -4743,7 +4743,7 @@
               </a:defRPr>
             </a:pPr>
             <a:r>
-              <a:t>Approach: stratified upscaling model linking my carbon-stability classes to flux observations</a:t>
+              <a:t>Approach: stratified upscaling linking CTrees AGB stability classes &amp; field carbon plots to tower and airborne flux observations</a:t>
             </a:r>
           </a:p>
         </p:txBody>
@@ -4850,7 +4850,7 @@
               </a:defRPr>
             </a:pPr>
             <a:r>
-              <a:t>Extend my tropical carbon-stability framework using CarbonARA's unique co-located measurements</a:t>
+              <a:t>Extend my CTrees AGB carbon-stability framework using CarbonARA's co-located flux and structure measurements</a:t>
             </a:r>
           </a:p>
           <a:p>
@@ -5639,7 +5639,7 @@
               </a:defRPr>
             </a:pPr>
             <a:r>
-              <a:t>Tropical Forest Carbon Stability — including Amazon</a:t>
+              <a:t>Tropical Forest Carbon Stability — CTrees AGB (2000–2025)</a:t>
             </a:r>
           </a:p>
         </p:txBody>
@@ -5670,7 +5670,7 @@
               </a:defRPr>
             </a:pPr>
             <a:r>
-              <a:t>Multi-biome extension of the same reproducible pipeline</a:t>
+              <a:t>Tracking when tropical forests lose carbon storage stability — not just canopy greenness</a:t>
             </a:r>
           </a:p>
           <a:p>
@@ -5685,7 +5685,7 @@
               </a:defRPr>
             </a:pPr>
             <a:r>
-              <a:t>Project: Tropical_forest_carbon_stability (Sundarbans + Amazon)</a:t>
+              <a:t>Project: Tropical_forest_carbon_stability — Sundarbans + Amazon</a:t>
             </a:r>
           </a:p>
           <a:p>
@@ -5700,7 +5700,7 @@
               </a:defRPr>
             </a:pPr>
             <a:r>
-              <a:t>Amazon: applied stability/resilience metrics to tropical terra firme forest landscapes</a:t>
+              <a:t>Data: CTrees global aboveground biomass (AGB), 100 m, annual 2000–2025</a:t>
             </a:r>
           </a:p>
           <a:p>
@@ -5715,7 +5715,7 @@
               </a:defRPr>
             </a:pPr>
             <a:r>
-              <a:t>Same workflow: long-term vegetation time series → perturbation → AC1/λ → stability class</a:t>
+              <a:t>   • Deep learning (DenseNet) fused with Landsat, ALOS PALSAR, GEDI/ICESat-2 structure</a:t>
             </a:r>
           </a:p>
           <a:p>
@@ -5730,7 +5730,7 @@
               </a:defRPr>
             </a:pPr>
             <a:r>
-              <a:t>Compares regions losing recovery capacity despite structurally intact canopy</a:t>
+              <a:t>   • Direct carbon-relevant metric (Mg ha⁻¹) — not just greenness indices</a:t>
             </a:r>
           </a:p>
           <a:p>
@@ -5745,7 +5745,7 @@
               </a:defRPr>
             </a:pPr>
             <a:r>
-              <a:t>Different stressors (cyclones vs drought/fire) — shared mechanism: carbon-climate feedback risk</a:t>
+              <a:t>Analysis: multi-year AGB time series → trend &amp; inter-annual variability → stability classes</a:t>
             </a:r>
           </a:p>
           <a:p>
@@ -5760,7 +5760,7 @@
               </a:defRPr>
             </a:pPr>
             <a:r>
-              <a:t>My role: extended pipeline to Amazon AOI, processed satellite stacks, spatial interpretation</a:t>
+              <a:t>   • Identify pixels/regions with declining biomass carbon despite persistent tree cover</a:t>
             </a:r>
           </a:p>
           <a:p>
@@ -5775,7 +5775,7 @@
               </a:defRPr>
             </a:pPr>
             <a:r>
-              <a:t>[INSERT FIGURE: Amazon stability map + study area inset]</a:t>
+              <a:t>   • Compare primary vs disturbed forest stability across biomes</a:t>
             </a:r>
           </a:p>
           <a:p>
@@ -5790,7 +5790,67 @@
               </a:defRPr>
             </a:pPr>
             <a:r>
-              <a:t>Direct relevance: eastern Amazon transition zone targeted by CarbonARA (Santarém, Pará)</a:t>
+              <a:t>Amazon: map where AGB carbon stocks are losing stability in eastern Amazon landscapes</a:t>
+            </a:r>
+          </a:p>
+          <a:p>
+            <a:pPr>
+              <a:spcAft>
+                <a:spcPts val="800"/>
+              </a:spcAft>
+              <a:defRPr sz="1700">
+                <a:solidFill>
+                  <a:srgbClr val="263238"/>
+                </a:solidFill>
+              </a:defRPr>
+            </a:pPr>
+            <a:r>
+              <a:t>Sundarbans: complementary to field inventory — landscape context for plot-scale sink degradation</a:t>
+            </a:r>
+          </a:p>
+          <a:p>
+            <a:pPr>
+              <a:spcAft>
+                <a:spcPts val="800"/>
+              </a:spcAft>
+              <a:defRPr sz="1700">
+                <a:solidFill>
+                  <a:srgbClr val="263238"/>
+                </a:solidFill>
+              </a:defRPr>
+            </a:pPr>
+            <a:r>
+              <a:t>My role: built Python pipeline, extracted CTrees stacks, computed stability metrics, mapped Amazon + Sundarbans</a:t>
+            </a:r>
+          </a:p>
+          <a:p>
+            <a:pPr>
+              <a:spcAft>
+                <a:spcPts val="800"/>
+              </a:spcAft>
+              <a:defRPr sz="1700">
+                <a:solidFill>
+                  <a:srgbClr val="263238"/>
+                </a:solidFill>
+              </a:defRPr>
+            </a:pPr>
+            <a:r>
+              <a:t>[INSERT FIGURE: CTrees ΔAGB or stability map — Amazon with Santarém/CarbonARA inset]</a:t>
+            </a:r>
+          </a:p>
+          <a:p>
+            <a:pPr>
+              <a:spcAft>
+                <a:spcPts val="800"/>
+              </a:spcAft>
+              <a:defRPr sz="1700">
+                <a:solidFill>
+                  <a:srgbClr val="263238"/>
+                </a:solidFill>
+              </a:defRPr>
+            </a:pPr>
+            <a:r>
+              <a:t>CarbonARA link: validate CTrees/BIOMASS against tower fluxes &amp; campaign biomass estimates</a:t>
             </a:r>
           </a:p>
         </p:txBody>
@@ -5910,6 +5970,21 @@
               </a:defRPr>
             </a:pPr>
             <a:r>
+              <a:t>Biomass carbon: CTrees AGB 100 m annual time series (2000–2025)</a:t>
+            </a:r>
+          </a:p>
+          <a:p>
+            <a:pPr>
+              <a:spcAft>
+                <a:spcPts val="600"/>
+              </a:spcAft>
+              <a:defRPr sz="1600">
+                <a:solidFill>
+                  <a:srgbClr val="263238"/>
+                </a:solidFill>
+              </a:defRPr>
+            </a:pPr>
+            <a:r>
               <a:t>Optical: Landsat 5–8, Sentinel-2, MODIS, PlanetScope, WorldView-2</a:t>
             </a:r>
           </a:p>
@@ -5940,7 +6015,7 @@
               </a:defRPr>
             </a:pPr>
             <a:r>
-              <a:t>Platforms: Google Earth Engine, Python, R, ENVI, SNAP</a:t>
+              <a:t>Platforms: Google Earth Engine, Python, R, AWS/Open Data (CTrees), ENVI, SNAP</a:t>
             </a:r>
           </a:p>
           <a:p>
@@ -6096,6 +6171,21 @@
             </a:pPr>
             <a:r>
               <a:t>Satellites: Sentinel-2/3/5P, FLEX, BIOMASS, MicroCarb, MetOp/IASI</a:t>
+            </a:r>
+          </a:p>
+          <a:p>
+            <a:pPr>
+              <a:spcAft>
+                <a:spcPts val="600"/>
+              </a:spcAft>
+              <a:defRPr sz="1600">
+                <a:solidFill>
+                  <a:srgbClr val="263238"/>
+                </a:solidFill>
+              </a:defRPr>
+            </a:pPr>
+            <a:r>
+              <a:t>Validation: compare CTrees/BIOMASS AGB with campaign biomass &amp; flux-derived NEE</a:t>
             </a:r>
           </a:p>
           <a:p>

</xml_diff>